<commit_message>
Milestone 3: update VM IP in docs, add allow_my_ip.sh
</commit_message>
<xml_diff>
--- a/docs/milestone3/gridpulse_milestone3.pptx
+++ b/docs/milestone3/gridpulse_milestone3.pptx
@@ -108,7 +108,7 @@
   <p:extLst>
     <p:ext uri="{521415D9-36F7-43E2-AB2F-B90AF26B5E84}">
       <p14:sectionLst xmlns:p14="http://schemas.microsoft.com/office/powerpoint/2010/main">
-        <p14:section name="Milestone 3" id="{cad2b8d9-3f9d-43b9-6c34-ec1ccef882c8}">
+        <p14:section name="Milestone 3" id="{d20bd8bc-1c29-bb2e-eabf-32462a80ea70}">
           <p14:sldIdLst>
             <p14:sldId id="256"/>
             <p14:sldId id="257"/>
@@ -3014,7 +3014,7 @@
                   <a:schemeClr val="bg2"/>
                 </a:solidFill>
               </a:rPr>
-              <a:t>http://23.251.144.238</a:t>
+              <a:t>http://35.184.90.182</a:t>
             </a:r>
             <a:endParaRPr lang="en-US" sz="1300" dirty="0"/>
           </a:p>

</xml_diff>